<commit_message>
Auto-save: 2 file(s) — 2026-10-05 13:08
</commit_message>
<xml_diff>
--- a/Projects/TekRevol/01-brand-system/deck-v6/TekRevol-Brand-Guidelines-Mono.pptx
+++ b/Projects/TekRevol/01-brand-system/deck-v6/TekRevol-Brand-Guidelines-Mono.pptx
@@ -2988,9 +2988,29 @@
           <a:chExt cx="0" cy="0"/>
         </a:xfrm>
       </p:grpSpPr>
+      <p:sp>
+        <p:nvSpPr>
+          <p:cNvPr id="3" name="Shape 0"/>
+          <p:cNvSpPr/>
+          <p:nvPr/>
+        </p:nvSpPr>
+        <p:spPr>
+          <a:xfrm>
+            <a:off x="0" y="4458789"/>
+            <a:ext cx="12192000" cy="1789611"/>
+          </a:xfrm>
+          <a:prstGeom prst="rect">
+            <a:avLst/>
+          </a:prstGeom>
+          <a:solidFill>
+            <a:srgbClr val="FF4A1C"/>
+          </a:solidFill>
+          <a:ln/>
+        </p:spPr>
+      </p:sp>
       <p:pic>
         <p:nvPicPr>
-          <p:cNvPr id="2" name="Image 0" descr="C:/Claude-Projects/Projects/TekRevol/01-brand-system/deck-v6/art/mono-iter-dark.png"/>
+          <p:cNvPr id="4" name="Image 1" descr="C:/Claude-Projects/Projects/TekRevol/01-brand-system/deck-v6/art/logo-white.png"/>
           <p:cNvPicPr>
             <a:picLocks noChangeAspect="1"/>
           </p:cNvPicPr>
@@ -3004,50 +3024,6 @@
         </p:blipFill>
         <p:spPr>
           <a:xfrm>
-            <a:off x="0" y="0"/>
-            <a:ext cx="12192000" cy="6858000"/>
-          </a:xfrm>
-          <a:prstGeom prst="rect">
-            <a:avLst/>
-          </a:prstGeom>
-        </p:spPr>
-      </p:pic>
-      <p:sp>
-        <p:nvSpPr>
-          <p:cNvPr id="3" name="Shape 0"/>
-          <p:cNvSpPr/>
-          <p:nvPr/>
-        </p:nvSpPr>
-        <p:spPr>
-          <a:xfrm>
-            <a:off x="0" y="4445000"/>
-            <a:ext cx="12192000" cy="2413000"/>
-          </a:xfrm>
-          <a:prstGeom prst="rect">
-            <a:avLst/>
-          </a:prstGeom>
-          <a:solidFill>
-            <a:srgbClr val="FF4A1C"/>
-          </a:solidFill>
-          <a:ln/>
-        </p:spPr>
-      </p:sp>
-      <p:pic>
-        <p:nvPicPr>
-          <p:cNvPr id="4" name="Image 1" descr="C:/Claude-Projects/Projects/TekRevol/01-brand-system/deck-v6/art/logo-white.png"/>
-          <p:cNvPicPr>
-            <a:picLocks noChangeAspect="1"/>
-          </p:cNvPicPr>
-          <p:nvPr/>
-        </p:nvPicPr>
-        <p:blipFill>
-          <a:blip r:embed="rId4"/>
-          <a:stretch>
-            <a:fillRect/>
-          </a:stretch>
-        </p:blipFill>
-        <p:spPr>
-          <a:xfrm>
             <a:off x="762000" y="609600"/>
             <a:ext cx="1905000" cy="279400"/>
           </a:xfrm>
@@ -3064,7 +3040,7 @@
         </p:nvSpPr>
         <p:spPr>
           <a:xfrm>
-            <a:off x="787400" y="3810000"/>
+            <a:off x="787400" y="4550230"/>
             <a:ext cx="7620000" cy="228600"/>
           </a:xfrm>
           <a:prstGeom prst="rect">
@@ -3106,7 +3082,7 @@
         </p:nvSpPr>
         <p:spPr>
           <a:xfrm>
-            <a:off x="736600" y="4711700"/>
+            <a:off x="762000" y="4826000"/>
             <a:ext cx="10795000" cy="952500"/>
           </a:xfrm>
           <a:prstGeom prst="rect">
@@ -3128,7 +3104,9 @@
             <a:r>
               <a:rPr lang="en-US" sz="6400" b="1" kern="0" spc="-154" dirty="0">
                 <a:solidFill>
-                  <a:srgbClr val="1D1E21"/>
+                  <a:schemeClr val="bg1">
+                    <a:lumMod val="95000"/>
+                  </a:schemeClr>
                 </a:solidFill>
                 <a:latin typeface="Funnel Display" pitchFamily="34" charset="0"/>
                 <a:ea typeface="Funnel Display" pitchFamily="34" charset="-122"/>
@@ -3136,7 +3114,13 @@
               </a:rPr>
               <a:t>Better with every layer.</a:t>
             </a:r>
-            <a:endParaRPr lang="en-US" sz="6400" dirty="0"/>
+            <a:endParaRPr lang="en-US" sz="6400" dirty="0">
+              <a:solidFill>
+                <a:schemeClr val="bg1">
+                  <a:lumMod val="95000"/>
+                </a:schemeClr>
+              </a:solidFill>
+            </a:endParaRPr>
           </a:p>
         </p:txBody>
       </p:sp>
@@ -25652,14 +25636,14 @@
       </p:sp>
       <p:sp>
         <p:nvSpPr>
-          <p:cNvPr id="7" name="Text 5"/>
-          <p:cNvSpPr/>
-          <p:nvPr/>
-        </p:nvSpPr>
-        <p:spPr>
-          <a:xfrm>
-            <a:off x="5588000" y="1587500"/>
-            <a:ext cx="5461000" cy="698500"/>
+          <p:cNvPr id="9" name="Text 7"/>
+          <p:cNvSpPr/>
+          <p:nvPr/>
+        </p:nvSpPr>
+        <p:spPr>
+          <a:xfrm>
+            <a:off x="5588000" y="1536700"/>
+            <a:ext cx="5461000" cy="952500"/>
           </a:xfrm>
           <a:prstGeom prst="rect">
             <a:avLst/>
@@ -25678,7 +25662,7 @@
               <a:buNone/>
             </a:pPr>
             <a:r>
-              <a:rPr lang="en-US" sz="1300" dirty="0">
+              <a:rPr lang="en-US" sz="1300" dirty="0" err="1">
                 <a:solidFill>
                   <a:srgbClr val="1D1E21"/>
                 </a:solidFill>
@@ -25686,81 +25670,8 @@
                 <a:ea typeface="Wix Madefor Text" pitchFamily="34" charset="-122"/>
                 <a:cs typeface="Wix Madefor Text" pitchFamily="34" charset="-120"/>
               </a:rPr>
-              <a:t>A mobile app studio built on structured chaos: learn, ideate, iterate, incubate and scale, in a constant state of flux.</a:t>
-            </a:r>
-            <a:endParaRPr lang="en-US" sz="1300" dirty="0"/>
-          </a:p>
-        </p:txBody>
-      </p:sp>
-      <p:sp>
-        <p:nvSpPr>
-          <p:cNvPr id="8" name="Text 6"/>
-          <p:cNvSpPr/>
-          <p:nvPr/>
-        </p:nvSpPr>
-        <p:spPr>
-          <a:xfrm>
-            <a:off x="5588000" y="2730500"/>
-            <a:ext cx="7620000" cy="203200"/>
-          </a:xfrm>
-          <a:prstGeom prst="rect">
-            <a:avLst/>
-          </a:prstGeom>
-          <a:noFill/>
-          <a:ln/>
-        </p:spPr>
-        <p:txBody>
-          <a:bodyPr wrap="square" lIns="0" tIns="0" rIns="0" bIns="0" rtlCol="0" anchor="t"/>
-          <a:lstStyle/>
-          <a:p>
-            <a:pPr marL="0" indent="0" algn="l">
-              <a:lnSpc>
-                <a:spcPct val="115000"/>
-              </a:lnSpc>
-              <a:buNone/>
-            </a:pPr>
-            <a:r>
-              <a:rPr lang="en-US" sz="800" kern="0" spc="144" dirty="0">
-                <a:solidFill>
-                  <a:srgbClr val="C2340E"/>
-                </a:solidFill>
-                <a:latin typeface="JetBrains Mono Medium" pitchFamily="34" charset="0"/>
-                <a:ea typeface="JetBrains Mono Medium" pitchFamily="34" charset="-122"/>
-                <a:cs typeface="JetBrains Mono Medium" pitchFamily="34" charset="-120"/>
-              </a:rPr>
-              <a:t>NOW</a:t>
-            </a:r>
-            <a:endParaRPr lang="en-US" sz="800" dirty="0"/>
-          </a:p>
-        </p:txBody>
-      </p:sp>
-      <p:sp>
-        <p:nvSpPr>
-          <p:cNvPr id="9" name="Text 7"/>
-          <p:cNvSpPr/>
-          <p:nvPr/>
-        </p:nvSpPr>
-        <p:spPr>
-          <a:xfrm>
-            <a:off x="5588000" y="2984500"/>
-            <a:ext cx="5461000" cy="952500"/>
-          </a:xfrm>
-          <a:prstGeom prst="rect">
-            <a:avLst/>
-          </a:prstGeom>
-          <a:noFill/>
-          <a:ln/>
-        </p:spPr>
-        <p:txBody>
-          <a:bodyPr wrap="square" lIns="0" tIns="0" rIns="0" bIns="0" rtlCol="0" anchor="t"/>
-          <a:lstStyle/>
-          <a:p>
-            <a:pPr marL="0" indent="0" algn="l">
-              <a:lnSpc>
-                <a:spcPct val="135000"/>
-              </a:lnSpc>
-              <a:buNone/>
-            </a:pPr>
+              <a:t>TekRevol</a:t>
+            </a:r>
             <a:r>
               <a:rPr lang="en-US" sz="1300" dirty="0">
                 <a:solidFill>
@@ -25770,7 +25681,7 @@
                 <a:ea typeface="Wix Madefor Text" pitchFamily="34" charset="-122"/>
                 <a:cs typeface="Wix Madefor Text" pitchFamily="34" charset="-120"/>
               </a:rPr>
-              <a:t>The same spirit, applied to AI. TekRevol adopts new technology early, experiments fast and keeps rebuilding until it works, then ships software enterprises can rely on.</a:t>
+              <a:t> adopts new technology early, experiments fast and keeps rebuilding until it works, then ships software enterprises can rely on.</a:t>
             </a:r>
             <a:endParaRPr lang="en-US" sz="1300" dirty="0"/>
           </a:p>

</xml_diff>